<commit_message>
feat: versiona los scripts de generacion del PPT (build_ppt + gen_mockups) con README y requirements; corrige tildes en nombres
</commit_message>
<xml_diff>
--- a/docs/presentacion_G15.pptx
+++ b/docs/presentacion_G15.pptx
@@ -3435,7 +3435,7 @@
                 </a:solidFill>
                 <a:latin typeface="Segoe UI"/>
               </a:rPr>
-              <a:t>Elias Gonzalez</a:t>
+              <a:t>Elías González</a:t>
             </a:r>
           </a:p>
         </p:txBody>
@@ -3524,7 +3524,7 @@
                 </a:solidFill>
                 <a:latin typeface="Segoe UI"/>
               </a:rPr>
-              <a:t>Enzo Dominguez</a:t>
+              <a:t>Enzo Domínguez</a:t>
             </a:r>
           </a:p>
         </p:txBody>
@@ -3613,7 +3613,7 @@
                 </a:solidFill>
                 <a:latin typeface="Segoe UI"/>
               </a:rPr>
-              <a:t>Nicolas Bareiro</a:t>
+              <a:t>Nicolás Bareiro</a:t>
             </a:r>
           </a:p>
         </p:txBody>
@@ -5078,7 +5078,7 @@
                 </a:solidFill>
                 <a:latin typeface="Segoe UI"/>
               </a:rPr>
-              <a:t>Grupo 15 · Elias Gonzalez · Enzo Dominguez · Nicolas Bareiro · FP-UNA 2026</a:t>
+              <a:t>Grupo 15 · Elías González · Enzo Domínguez · Nicolás Bareiro · FP-UNA 2026</a:t>
             </a:r>
           </a:p>
         </p:txBody>

</xml_diff>

<commit_message>
docs: actualiza el UML embebido en el PPT al nuevo diagrama profesional y ajusta la leyenda
</commit_message>
<xml_diff>
--- a/docs/presentacion_G15.pptx
+++ b/docs/presentacion_G15.pptx
@@ -5175,6 +5175,925 @@
 </file>
 
 <file path=ppt/slides/slide12.xml><?xml version="1.0" encoding="utf-8"?>
+<p:sld xmlns:a="http://schemas.openxmlformats.org/drawingml/2006/main" xmlns:p="http://schemas.openxmlformats.org/presentationml/2006/main" xmlns:r="http://schemas.openxmlformats.org/officeDocument/2006/relationships">
+  <p:cSld>
+    <p:spTree>
+      <p:nvGrpSpPr>
+        <p:cNvPr id="1" name=""/>
+        <p:cNvGrpSpPr/>
+        <p:nvPr/>
+      </p:nvGrpSpPr>
+      <p:grpSpPr/>
+      <p:sp>
+        <p:nvSpPr>
+          <p:cNvPr id="2" name="Rectangle 1"/>
+          <p:cNvSpPr/>
+          <p:nvPr/>
+        </p:nvSpPr>
+        <p:spPr>
+          <a:xfrm>
+            <a:off x="0" y="0"/>
+            <a:ext cx="12191695" cy="6858000"/>
+          </a:xfrm>
+          <a:prstGeom prst="rect">
+            <a:avLst/>
+          </a:prstGeom>
+          <a:solidFill>
+            <a:srgbClr val="F8FAFC"/>
+          </a:solidFill>
+          <a:ln>
+            <a:noFill/>
+          </a:ln>
+          <a:effectLst/>
+        </p:spPr>
+        <p:style>
+          <a:lnRef idx="1">
+            <a:schemeClr val="accent1"/>
+          </a:lnRef>
+          <a:fillRef idx="3">
+            <a:schemeClr val="accent1"/>
+          </a:fillRef>
+          <a:effectRef idx="2">
+            <a:schemeClr val="accent1"/>
+          </a:effectRef>
+          <a:fontRef idx="minor">
+            <a:schemeClr val="lt1"/>
+          </a:fontRef>
+        </p:style>
+        <p:txBody>
+          <a:bodyPr rtlCol="0" anchor="ctr"/>
+          <a:lstStyle/>
+          <a:p>
+            <a:pPr algn="ctr"/>
+          </a:p>
+        </p:txBody>
+      </p:sp>
+      <p:sp>
+        <p:nvSpPr>
+          <p:cNvPr id="3" name="Rectangle 2"/>
+          <p:cNvSpPr/>
+          <p:nvPr/>
+        </p:nvSpPr>
+        <p:spPr>
+          <a:xfrm>
+            <a:off x="0" y="0"/>
+            <a:ext cx="12191695" cy="109728"/>
+          </a:xfrm>
+          <a:prstGeom prst="rect">
+            <a:avLst/>
+          </a:prstGeom>
+          <a:solidFill>
+            <a:srgbClr val="10B981"/>
+          </a:solidFill>
+          <a:ln>
+            <a:noFill/>
+          </a:ln>
+          <a:effectLst/>
+        </p:spPr>
+        <p:style>
+          <a:lnRef idx="1">
+            <a:schemeClr val="accent1"/>
+          </a:lnRef>
+          <a:fillRef idx="3">
+            <a:schemeClr val="accent1"/>
+          </a:fillRef>
+          <a:effectRef idx="2">
+            <a:schemeClr val="accent1"/>
+          </a:effectRef>
+          <a:fontRef idx="minor">
+            <a:schemeClr val="lt1"/>
+          </a:fontRef>
+        </p:style>
+        <p:txBody>
+          <a:bodyPr rtlCol="0" anchor="ctr"/>
+          <a:lstStyle/>
+          <a:p>
+            <a:pPr algn="ctr"/>
+          </a:p>
+        </p:txBody>
+      </p:sp>
+      <p:sp>
+        <p:nvSpPr>
+          <p:cNvPr id="4" name="Rectangle 3"/>
+          <p:cNvSpPr/>
+          <p:nvPr/>
+        </p:nvSpPr>
+        <p:spPr>
+          <a:xfrm>
+            <a:off x="0" y="6784848"/>
+            <a:ext cx="12191695" cy="73152"/>
+          </a:xfrm>
+          <a:prstGeom prst="rect">
+            <a:avLst/>
+          </a:prstGeom>
+          <a:solidFill>
+            <a:srgbClr val="0B1220"/>
+          </a:solidFill>
+          <a:ln>
+            <a:noFill/>
+          </a:ln>
+          <a:effectLst/>
+        </p:spPr>
+        <p:style>
+          <a:lnRef idx="1">
+            <a:schemeClr val="accent1"/>
+          </a:lnRef>
+          <a:fillRef idx="3">
+            <a:schemeClr val="accent1"/>
+          </a:fillRef>
+          <a:effectRef idx="2">
+            <a:schemeClr val="accent1"/>
+          </a:effectRef>
+          <a:fontRef idx="minor">
+            <a:schemeClr val="lt1"/>
+          </a:fontRef>
+        </p:style>
+        <p:txBody>
+          <a:bodyPr rtlCol="0" anchor="ctr"/>
+          <a:lstStyle/>
+          <a:p>
+            <a:pPr algn="ctr"/>
+          </a:p>
+        </p:txBody>
+      </p:sp>
+      <p:sp>
+        <p:nvSpPr>
+          <p:cNvPr id="5" name="TextBox 4"/>
+          <p:cNvSpPr txBox="1"/>
+          <p:nvPr/>
+        </p:nvSpPr>
+        <p:spPr>
+          <a:xfrm>
+            <a:off x="566928" y="320040"/>
+            <a:ext cx="7315200" cy="228600"/>
+          </a:xfrm>
+          <a:prstGeom prst="rect">
+            <a:avLst/>
+          </a:prstGeom>
+          <a:noFill/>
+        </p:spPr>
+        <p:txBody>
+          <a:bodyPr wrap="square" anchor="t">
+            <a:noAutofit/>
+          </a:bodyPr>
+          <a:lstStyle/>
+          <a:p>
+            <a:pPr algn="l"/>
+            <a:r>
+              <a:rPr sz="1100" b="1">
+                <a:solidFill>
+                  <a:srgbClr val="047857"/>
+                </a:solidFill>
+                <a:latin typeface="Segoe UI"/>
+              </a:rPr>
+              <a:t>DISEÑO DE CLASES</a:t>
+            </a:r>
+          </a:p>
+        </p:txBody>
+      </p:sp>
+      <p:sp>
+        <p:nvSpPr>
+          <p:cNvPr id="6" name="TextBox 5"/>
+          <p:cNvSpPr txBox="1"/>
+          <p:nvPr/>
+        </p:nvSpPr>
+        <p:spPr>
+          <a:xfrm>
+            <a:off x="548640" y="566928"/>
+            <a:ext cx="10698480" cy="548640"/>
+          </a:xfrm>
+          <a:prstGeom prst="rect">
+            <a:avLst/>
+          </a:prstGeom>
+          <a:noFill/>
+        </p:spPr>
+        <p:txBody>
+          <a:bodyPr wrap="square" anchor="t">
+            <a:noAutofit/>
+          </a:bodyPr>
+          <a:lstStyle/>
+          <a:p>
+            <a:pPr algn="l"/>
+            <a:r>
+              <a:rPr sz="2600" b="1">
+                <a:solidFill>
+                  <a:srgbClr val="0B1220"/>
+                </a:solidFill>
+                <a:latin typeface="Segoe UI Semibold"/>
+              </a:rPr>
+              <a:t>El modelo del sistema (UML)</a:t>
+            </a:r>
+          </a:p>
+        </p:txBody>
+      </p:sp>
+      <p:sp>
+        <p:nvSpPr>
+          <p:cNvPr id="7" name="Rectangle 6"/>
+          <p:cNvSpPr/>
+          <p:nvPr/>
+        </p:nvSpPr>
+        <p:spPr>
+          <a:xfrm>
+            <a:off x="566928" y="1179576"/>
+            <a:ext cx="11064240" cy="15240"/>
+          </a:xfrm>
+          <a:prstGeom prst="rect">
+            <a:avLst/>
+          </a:prstGeom>
+          <a:solidFill>
+            <a:srgbClr val="E2E8F0"/>
+          </a:solidFill>
+          <a:ln>
+            <a:noFill/>
+          </a:ln>
+          <a:effectLst/>
+        </p:spPr>
+        <p:style>
+          <a:lnRef idx="1">
+            <a:schemeClr val="accent1"/>
+          </a:lnRef>
+          <a:fillRef idx="3">
+            <a:schemeClr val="accent1"/>
+          </a:fillRef>
+          <a:effectRef idx="2">
+            <a:schemeClr val="accent1"/>
+          </a:effectRef>
+          <a:fontRef idx="minor">
+            <a:schemeClr val="lt1"/>
+          </a:fontRef>
+        </p:style>
+        <p:txBody>
+          <a:bodyPr rtlCol="0" anchor="ctr"/>
+          <a:lstStyle/>
+          <a:p>
+            <a:pPr algn="ctr"/>
+          </a:p>
+        </p:txBody>
+      </p:sp>
+      <p:sp>
+        <p:nvSpPr>
+          <p:cNvPr id="8" name="TextBox 7"/>
+          <p:cNvSpPr txBox="1"/>
+          <p:nvPr/>
+        </p:nvSpPr>
+        <p:spPr>
+          <a:xfrm>
+            <a:off x="566928" y="6528816"/>
+            <a:ext cx="8229600" cy="182880"/>
+          </a:xfrm>
+          <a:prstGeom prst="rect">
+            <a:avLst/>
+          </a:prstGeom>
+          <a:noFill/>
+        </p:spPr>
+        <p:txBody>
+          <a:bodyPr wrap="square" anchor="t">
+            <a:noAutofit/>
+          </a:bodyPr>
+          <a:lstStyle/>
+          <a:p>
+            <a:pPr algn="l"/>
+            <a:r>
+              <a:rPr sz="800" b="0">
+                <a:solidFill>
+                  <a:srgbClr val="64748B"/>
+                </a:solidFill>
+                <a:latin typeface="Segoe UI"/>
+              </a:rPr>
+              <a:t>Sistema de Gestión de Eventos · Paradigmas de la Programación · FP-UNA 2026</a:t>
+            </a:r>
+          </a:p>
+        </p:txBody>
+      </p:sp>
+      <p:sp>
+        <p:nvSpPr>
+          <p:cNvPr id="9" name="TextBox 8"/>
+          <p:cNvSpPr txBox="1"/>
+          <p:nvPr/>
+        </p:nvSpPr>
+        <p:spPr>
+          <a:xfrm>
+            <a:off x="11192256" y="6492240"/>
+            <a:ext cx="548640" cy="201168"/>
+          </a:xfrm>
+          <a:prstGeom prst="rect">
+            <a:avLst/>
+          </a:prstGeom>
+          <a:noFill/>
+        </p:spPr>
+        <p:txBody>
+          <a:bodyPr wrap="square" anchor="t">
+            <a:noAutofit/>
+          </a:bodyPr>
+          <a:lstStyle/>
+          <a:p>
+            <a:pPr algn="r"/>
+            <a:r>
+              <a:rPr sz="900" b="1">
+                <a:solidFill>
+                  <a:srgbClr val="64748B"/>
+                </a:solidFill>
+                <a:latin typeface="Segoe UI"/>
+              </a:rPr>
+              <a:t>12</a:t>
+            </a:r>
+          </a:p>
+        </p:txBody>
+      </p:sp>
+      <p:sp>
+        <p:nvSpPr>
+          <p:cNvPr id="10" name="Rounded Rectangle 9"/>
+          <p:cNvSpPr/>
+          <p:nvPr/>
+        </p:nvSpPr>
+        <p:spPr>
+          <a:xfrm>
+            <a:off x="1078992" y="1307592"/>
+            <a:ext cx="3211339" cy="4974336"/>
+          </a:xfrm>
+          <a:prstGeom prst="roundRect">
+            <a:avLst/>
+          </a:prstGeom>
+          <a:solidFill>
+            <a:srgbClr val="FFFFFF"/>
+          </a:solidFill>
+          <a:ln w="9525">
+            <a:solidFill>
+              <a:srgbClr val="E2E8F0"/>
+            </a:solidFill>
+          </a:ln>
+          <a:effectLst/>
+        </p:spPr>
+        <p:style>
+          <a:lnRef idx="1">
+            <a:schemeClr val="accent1"/>
+          </a:lnRef>
+          <a:fillRef idx="3">
+            <a:schemeClr val="accent1"/>
+          </a:fillRef>
+          <a:effectRef idx="2">
+            <a:schemeClr val="accent1"/>
+          </a:effectRef>
+          <a:fontRef idx="minor">
+            <a:schemeClr val="lt1"/>
+          </a:fontRef>
+        </p:style>
+        <p:txBody>
+          <a:bodyPr rtlCol="0" anchor="ctr"/>
+          <a:lstStyle/>
+          <a:p>
+            <a:pPr algn="ctr"/>
+          </a:p>
+        </p:txBody>
+      </p:sp>
+      <p:sp>
+        <p:nvSpPr>
+          <p:cNvPr id="12" name="TextBox 11"/>
+          <p:cNvSpPr txBox="1"/>
+          <p:nvPr/>
+        </p:nvSpPr>
+        <p:spPr>
+          <a:xfrm>
+            <a:off x="7040880" y="1417320"/>
+            <a:ext cx="4572000" cy="365760"/>
+          </a:xfrm>
+          <a:prstGeom prst="rect">
+            <a:avLst/>
+          </a:prstGeom>
+          <a:noFill/>
+        </p:spPr>
+        <p:txBody>
+          <a:bodyPr wrap="square" anchor="t">
+            <a:noAutofit/>
+          </a:bodyPr>
+          <a:lstStyle/>
+          <a:p>
+            <a:pPr algn="l"/>
+            <a:r>
+              <a:rPr sz="1600" b="1">
+                <a:solidFill>
+                  <a:srgbClr val="0B1220"/>
+                </a:solidFill>
+                <a:latin typeface="Segoe UI Semibold"/>
+              </a:rPr>
+              <a:t>Cómo leer el diagrama</a:t>
+            </a:r>
+          </a:p>
+        </p:txBody>
+      </p:sp>
+      <p:sp>
+        <p:nvSpPr>
+          <p:cNvPr id="13" name="Rounded Rectangle 12"/>
+          <p:cNvSpPr/>
+          <p:nvPr/>
+        </p:nvSpPr>
+        <p:spPr>
+          <a:xfrm>
+            <a:off x="7040880" y="1965960"/>
+            <a:ext cx="4572000" cy="1143000"/>
+          </a:xfrm>
+          <a:prstGeom prst="roundRect">
+            <a:avLst/>
+          </a:prstGeom>
+          <a:solidFill>
+            <a:srgbClr val="FFFFFF"/>
+          </a:solidFill>
+          <a:ln w="9525">
+            <a:solidFill>
+              <a:srgbClr val="E2E8F0"/>
+            </a:solidFill>
+          </a:ln>
+          <a:effectLst/>
+        </p:spPr>
+        <p:style>
+          <a:lnRef idx="1">
+            <a:schemeClr val="accent1"/>
+          </a:lnRef>
+          <a:fillRef idx="3">
+            <a:schemeClr val="accent1"/>
+          </a:fillRef>
+          <a:effectRef idx="2">
+            <a:schemeClr val="accent1"/>
+          </a:effectRef>
+          <a:fontRef idx="minor">
+            <a:schemeClr val="lt1"/>
+          </a:fontRef>
+        </p:style>
+        <p:txBody>
+          <a:bodyPr rtlCol="0" anchor="ctr"/>
+          <a:lstStyle/>
+          <a:p>
+            <a:pPr algn="ctr"/>
+          </a:p>
+        </p:txBody>
+      </p:sp>
+      <p:sp>
+        <p:nvSpPr>
+          <p:cNvPr id="14" name="Rectangle 13"/>
+          <p:cNvSpPr/>
+          <p:nvPr/>
+        </p:nvSpPr>
+        <p:spPr>
+          <a:xfrm>
+            <a:off x="7040880" y="1965960"/>
+            <a:ext cx="73152" cy="1143000"/>
+          </a:xfrm>
+          <a:prstGeom prst="rect">
+            <a:avLst/>
+          </a:prstGeom>
+          <a:solidFill>
+            <a:srgbClr val="10B981"/>
+          </a:solidFill>
+          <a:ln>
+            <a:noFill/>
+          </a:ln>
+          <a:effectLst/>
+        </p:spPr>
+        <p:style>
+          <a:lnRef idx="1">
+            <a:schemeClr val="accent1"/>
+          </a:lnRef>
+          <a:fillRef idx="3">
+            <a:schemeClr val="accent1"/>
+          </a:fillRef>
+          <a:effectRef idx="2">
+            <a:schemeClr val="accent1"/>
+          </a:effectRef>
+          <a:fontRef idx="minor">
+            <a:schemeClr val="lt1"/>
+          </a:fontRef>
+        </p:style>
+        <p:txBody>
+          <a:bodyPr rtlCol="0" anchor="ctr"/>
+          <a:lstStyle/>
+          <a:p>
+            <a:pPr algn="ctr"/>
+          </a:p>
+        </p:txBody>
+      </p:sp>
+      <p:sp>
+        <p:nvSpPr>
+          <p:cNvPr id="15" name="TextBox 14"/>
+          <p:cNvSpPr txBox="1"/>
+          <p:nvPr/>
+        </p:nvSpPr>
+        <p:spPr>
+          <a:xfrm>
+            <a:off x="7269480" y="2093976"/>
+            <a:ext cx="4160520" cy="320040"/>
+          </a:xfrm>
+          <a:prstGeom prst="rect">
+            <a:avLst/>
+          </a:prstGeom>
+          <a:noFill/>
+        </p:spPr>
+        <p:txBody>
+          <a:bodyPr wrap="square" anchor="t">
+            <a:noAutofit/>
+          </a:bodyPr>
+          <a:lstStyle/>
+          <a:p>
+            <a:pPr algn="l"/>
+            <a:r>
+              <a:rPr sz="1400" b="1">
+                <a:solidFill>
+                  <a:srgbClr val="0B1220"/>
+                </a:solidFill>
+                <a:latin typeface="Segoe UI Semibold"/>
+              </a:rPr>
+              <a:t>Herencia</a:t>
+            </a:r>
+          </a:p>
+        </p:txBody>
+      </p:sp>
+      <p:sp>
+        <p:nvSpPr>
+          <p:cNvPr id="16" name="TextBox 15"/>
+          <p:cNvSpPr txBox="1"/>
+          <p:nvPr/>
+        </p:nvSpPr>
+        <p:spPr>
+          <a:xfrm>
+            <a:off x="7269480" y="2468880"/>
+            <a:ext cx="4160520" cy="548640"/>
+          </a:xfrm>
+          <a:prstGeom prst="rect">
+            <a:avLst/>
+          </a:prstGeom>
+          <a:noFill/>
+        </p:spPr>
+        <p:txBody>
+          <a:bodyPr wrap="square" anchor="t">
+            <a:noAutofit/>
+          </a:bodyPr>
+          <a:lstStyle/>
+          <a:p>
+            <a:pPr algn="l"/>
+            <a:r>
+              <a:rPr sz="1100" b="0">
+                <a:solidFill>
+                  <a:srgbClr val="111827"/>
+                </a:solidFill>
+                <a:latin typeface="Segoe UI"/>
+              </a:rPr>
+              <a:t>EventoDeportivo ES una AgendaEventos especializada (triángulo hueco).</a:t>
+            </a:r>
+          </a:p>
+        </p:txBody>
+      </p:sp>
+      <p:sp>
+        <p:nvSpPr>
+          <p:cNvPr id="17" name="Rounded Rectangle 16"/>
+          <p:cNvSpPr/>
+          <p:nvPr/>
+        </p:nvSpPr>
+        <p:spPr>
+          <a:xfrm>
+            <a:off x="7040880" y="3291839"/>
+            <a:ext cx="4572000" cy="1143000"/>
+          </a:xfrm>
+          <a:prstGeom prst="roundRect">
+            <a:avLst/>
+          </a:prstGeom>
+          <a:solidFill>
+            <a:srgbClr val="FFFFFF"/>
+          </a:solidFill>
+          <a:ln w="9525">
+            <a:solidFill>
+              <a:srgbClr val="E2E8F0"/>
+            </a:solidFill>
+          </a:ln>
+          <a:effectLst/>
+        </p:spPr>
+        <p:style>
+          <a:lnRef idx="1">
+            <a:schemeClr val="accent1"/>
+          </a:lnRef>
+          <a:fillRef idx="3">
+            <a:schemeClr val="accent1"/>
+          </a:fillRef>
+          <a:effectRef idx="2">
+            <a:schemeClr val="accent1"/>
+          </a:effectRef>
+          <a:fontRef idx="minor">
+            <a:schemeClr val="lt1"/>
+          </a:fontRef>
+        </p:style>
+        <p:txBody>
+          <a:bodyPr rtlCol="0" anchor="ctr"/>
+          <a:lstStyle/>
+          <a:p>
+            <a:pPr algn="ctr"/>
+          </a:p>
+        </p:txBody>
+      </p:sp>
+      <p:sp>
+        <p:nvSpPr>
+          <p:cNvPr id="18" name="Rectangle 17"/>
+          <p:cNvSpPr/>
+          <p:nvPr/>
+        </p:nvSpPr>
+        <p:spPr>
+          <a:xfrm>
+            <a:off x="7040880" y="3291839"/>
+            <a:ext cx="73152" cy="1143000"/>
+          </a:xfrm>
+          <a:prstGeom prst="rect">
+            <a:avLst/>
+          </a:prstGeom>
+          <a:solidFill>
+            <a:srgbClr val="2563EB"/>
+          </a:solidFill>
+          <a:ln>
+            <a:noFill/>
+          </a:ln>
+          <a:effectLst/>
+        </p:spPr>
+        <p:style>
+          <a:lnRef idx="1">
+            <a:schemeClr val="accent1"/>
+          </a:lnRef>
+          <a:fillRef idx="3">
+            <a:schemeClr val="accent1"/>
+          </a:fillRef>
+          <a:effectRef idx="2">
+            <a:schemeClr val="accent1"/>
+          </a:effectRef>
+          <a:fontRef idx="minor">
+            <a:schemeClr val="lt1"/>
+          </a:fontRef>
+        </p:style>
+        <p:txBody>
+          <a:bodyPr rtlCol="0" anchor="ctr"/>
+          <a:lstStyle/>
+          <a:p>
+            <a:pPr algn="ctr"/>
+          </a:p>
+        </p:txBody>
+      </p:sp>
+      <p:sp>
+        <p:nvSpPr>
+          <p:cNvPr id="19" name="TextBox 18"/>
+          <p:cNvSpPr txBox="1"/>
+          <p:nvPr/>
+        </p:nvSpPr>
+        <p:spPr>
+          <a:xfrm>
+            <a:off x="7269480" y="3419856"/>
+            <a:ext cx="4160520" cy="320040"/>
+          </a:xfrm>
+          <a:prstGeom prst="rect">
+            <a:avLst/>
+          </a:prstGeom>
+          <a:noFill/>
+        </p:spPr>
+        <p:txBody>
+          <a:bodyPr wrap="square" anchor="t">
+            <a:noAutofit/>
+          </a:bodyPr>
+          <a:lstStyle/>
+          <a:p>
+            <a:pPr algn="l"/>
+            <a:r>
+              <a:rPr sz="1400" b="1">
+                <a:solidFill>
+                  <a:srgbClr val="0B1220"/>
+                </a:solidFill>
+                <a:latin typeface="Segoe UI Semibold"/>
+              </a:rPr>
+              <a:t>Composición</a:t>
+            </a:r>
+          </a:p>
+        </p:txBody>
+      </p:sp>
+      <p:sp>
+        <p:nvSpPr>
+          <p:cNvPr id="20" name="TextBox 19"/>
+          <p:cNvSpPr txBox="1"/>
+          <p:nvPr/>
+        </p:nvSpPr>
+        <p:spPr>
+          <a:xfrm>
+            <a:off x="7269480" y="3794759"/>
+            <a:ext cx="4160520" cy="548640"/>
+          </a:xfrm>
+          <a:prstGeom prst="rect">
+            <a:avLst/>
+          </a:prstGeom>
+          <a:noFill/>
+        </p:spPr>
+        <p:txBody>
+          <a:bodyPr wrap="square" anchor="t">
+            <a:noAutofit/>
+          </a:bodyPr>
+          <a:lstStyle/>
+          <a:p>
+            <a:pPr algn="l"/>
+            <a:r>
+              <a:rPr sz="1100" b="0">
+                <a:solidFill>
+                  <a:srgbClr val="111827"/>
+                </a:solidFill>
+                <a:latin typeface="Segoe UI"/>
+              </a:rPr>
+              <a:t>La agenda contiene de 0 a muchos Evento (rombo relleno, multiplicidad 0..*).</a:t>
+            </a:r>
+          </a:p>
+        </p:txBody>
+      </p:sp>
+      <p:sp>
+        <p:nvSpPr>
+          <p:cNvPr id="21" name="Rounded Rectangle 20"/>
+          <p:cNvSpPr/>
+          <p:nvPr/>
+        </p:nvSpPr>
+        <p:spPr>
+          <a:xfrm>
+            <a:off x="7040880" y="4617720"/>
+            <a:ext cx="4572000" cy="1143000"/>
+          </a:xfrm>
+          <a:prstGeom prst="roundRect">
+            <a:avLst/>
+          </a:prstGeom>
+          <a:solidFill>
+            <a:srgbClr val="FFFFFF"/>
+          </a:solidFill>
+          <a:ln w="9525">
+            <a:solidFill>
+              <a:srgbClr val="E2E8F0"/>
+            </a:solidFill>
+          </a:ln>
+          <a:effectLst/>
+        </p:spPr>
+        <p:style>
+          <a:lnRef idx="1">
+            <a:schemeClr val="accent1"/>
+          </a:lnRef>
+          <a:fillRef idx="3">
+            <a:schemeClr val="accent1"/>
+          </a:fillRef>
+          <a:effectRef idx="2">
+            <a:schemeClr val="accent1"/>
+          </a:effectRef>
+          <a:fontRef idx="minor">
+            <a:schemeClr val="lt1"/>
+          </a:fontRef>
+        </p:style>
+        <p:txBody>
+          <a:bodyPr rtlCol="0" anchor="ctr"/>
+          <a:lstStyle/>
+          <a:p>
+            <a:pPr algn="ctr"/>
+          </a:p>
+        </p:txBody>
+      </p:sp>
+      <p:sp>
+        <p:nvSpPr>
+          <p:cNvPr id="22" name="Rectangle 21"/>
+          <p:cNvSpPr/>
+          <p:nvPr/>
+        </p:nvSpPr>
+        <p:spPr>
+          <a:xfrm>
+            <a:off x="7040880" y="4617720"/>
+            <a:ext cx="73152" cy="1143000"/>
+          </a:xfrm>
+          <a:prstGeom prst="rect">
+            <a:avLst/>
+          </a:prstGeom>
+          <a:solidFill>
+            <a:srgbClr val="F59E0B"/>
+          </a:solidFill>
+          <a:ln>
+            <a:noFill/>
+          </a:ln>
+          <a:effectLst/>
+        </p:spPr>
+        <p:style>
+          <a:lnRef idx="1">
+            <a:schemeClr val="accent1"/>
+          </a:lnRef>
+          <a:fillRef idx="3">
+            <a:schemeClr val="accent1"/>
+          </a:fillRef>
+          <a:effectRef idx="2">
+            <a:schemeClr val="accent1"/>
+          </a:effectRef>
+          <a:fontRef idx="minor">
+            <a:schemeClr val="lt1"/>
+          </a:fontRef>
+        </p:style>
+        <p:txBody>
+          <a:bodyPr rtlCol="0" anchor="ctr"/>
+          <a:lstStyle/>
+          <a:p>
+            <a:pPr algn="ctr"/>
+          </a:p>
+        </p:txBody>
+      </p:sp>
+      <p:sp>
+        <p:nvSpPr>
+          <p:cNvPr id="23" name="TextBox 22"/>
+          <p:cNvSpPr txBox="1"/>
+          <p:nvPr/>
+        </p:nvSpPr>
+        <p:spPr>
+          <a:xfrm>
+            <a:off x="7269480" y="4745736"/>
+            <a:ext cx="4160520" cy="320040"/>
+          </a:xfrm>
+          <a:prstGeom prst="rect">
+            <a:avLst/>
+          </a:prstGeom>
+          <a:noFill/>
+        </p:spPr>
+        <p:txBody>
+          <a:bodyPr wrap="square" anchor="t">
+            <a:noAutofit/>
+          </a:bodyPr>
+          <a:lstStyle/>
+          <a:p>
+            <a:pPr algn="l"/>
+            <a:r>
+              <a:rPr sz="1400" b="1">
+                <a:solidFill>
+                  <a:srgbClr val="0B1220"/>
+                </a:solidFill>
+                <a:latin typeface="Segoe UI Semibold"/>
+              </a:rPr>
+              <a:t>Validación</a:t>
+            </a:r>
+          </a:p>
+        </p:txBody>
+      </p:sp>
+      <p:sp>
+        <p:nvSpPr>
+          <p:cNvPr id="24" name="TextBox 23"/>
+          <p:cNvSpPr txBox="1"/>
+          <p:nvPr/>
+        </p:nvSpPr>
+        <p:spPr>
+          <a:xfrm>
+            <a:off x="7269480" y="5120640"/>
+            <a:ext cx="4160520" cy="548640"/>
+          </a:xfrm>
+          <a:prstGeom prst="rect">
+            <a:avLst/>
+          </a:prstGeom>
+          <a:noFill/>
+        </p:spPr>
+        <p:txBody>
+          <a:bodyPr wrap="square" anchor="t">
+            <a:noAutofit/>
+          </a:bodyPr>
+          <a:lstStyle/>
+          <a:p>
+            <a:pPr algn="l"/>
+            <a:r>
+              <a:rPr sz="1100" b="0">
+                <a:solidFill>
+                  <a:srgbClr val="111827"/>
+                </a:solidFill>
+                <a:latin typeface="Segoe UI"/>
+              </a:rPr>
+              <a:t>Atributos sensibles protegidos con properties (fecha, cupo, ventas).</a:t>
+            </a:r>
+          </a:p>
+        </p:txBody>
+      </p:sp>
+      <p:pic>
+        <p:nvPicPr>
+          <p:cNvPr id="25" name="Picture 24" descr="diagrama_G15.png"/>
+          <p:cNvPicPr>
+            <a:picLocks noChangeAspect="1"/>
+          </p:cNvPicPr>
+          <p:nvPr/>
+        </p:nvPicPr>
+        <p:blipFill>
+          <a:blip r:embed="rId3"/>
+          <a:stretch>
+            <a:fillRect/>
+          </a:stretch>
+        </p:blipFill>
+        <p:spPr>
+          <a:xfrm>
+            <a:off x="1188720" y="1417320"/>
+            <a:ext cx="2991883" cy="4754880"/>
+          </a:xfrm>
+          <a:prstGeom prst="rect">
+            <a:avLst/>
+          </a:prstGeom>
+        </p:spPr>
+      </p:pic>
+    </p:spTree>
+  </p:cSld>
+  <p:clrMapOvr>
+    <a:masterClrMapping/>
+  </p:clrMapOvr>
+</p:sld>
+</file>
+
+<file path=ppt/slides/slide13.xml><?xml version="1.0" encoding="utf-8"?>
 <p:sld xmlns:a="http://schemas.openxmlformats.org/drawingml/2006/main" xmlns:r="http://schemas.openxmlformats.org/officeDocument/2006/relationships" xmlns:p="http://schemas.openxmlformats.org/presentationml/2006/main">
   <p:cSld name="Slide 12">
     <p:bg>
@@ -5847,925 +6766,6 @@
           </a:prstGeom>
         </p:spPr>
       </p:pic>
-    </p:spTree>
-  </p:cSld>
-  <p:clrMapOvr>
-    <a:masterClrMapping/>
-  </p:clrMapOvr>
-</p:sld>
-</file>
-
-<file path=ppt/slides/slide13.xml><?xml version="1.0" encoding="utf-8"?>
-<p:sld xmlns:a="http://schemas.openxmlformats.org/drawingml/2006/main" xmlns:p="http://schemas.openxmlformats.org/presentationml/2006/main" xmlns:r="http://schemas.openxmlformats.org/officeDocument/2006/relationships">
-  <p:cSld>
-    <p:spTree>
-      <p:nvGrpSpPr>
-        <p:cNvPr id="1" name=""/>
-        <p:cNvGrpSpPr/>
-        <p:nvPr/>
-      </p:nvGrpSpPr>
-      <p:grpSpPr/>
-      <p:sp>
-        <p:nvSpPr>
-          <p:cNvPr id="2" name="Rectangle 1"/>
-          <p:cNvSpPr/>
-          <p:nvPr/>
-        </p:nvSpPr>
-        <p:spPr>
-          <a:xfrm>
-            <a:off x="0" y="0"/>
-            <a:ext cx="12191695" cy="6858000"/>
-          </a:xfrm>
-          <a:prstGeom prst="rect">
-            <a:avLst/>
-          </a:prstGeom>
-          <a:solidFill>
-            <a:srgbClr val="F8FAFC"/>
-          </a:solidFill>
-          <a:ln>
-            <a:noFill/>
-          </a:ln>
-          <a:effectLst/>
-        </p:spPr>
-        <p:style>
-          <a:lnRef idx="1">
-            <a:schemeClr val="accent1"/>
-          </a:lnRef>
-          <a:fillRef idx="3">
-            <a:schemeClr val="accent1"/>
-          </a:fillRef>
-          <a:effectRef idx="2">
-            <a:schemeClr val="accent1"/>
-          </a:effectRef>
-          <a:fontRef idx="minor">
-            <a:schemeClr val="lt1"/>
-          </a:fontRef>
-        </p:style>
-        <p:txBody>
-          <a:bodyPr rtlCol="0" anchor="ctr"/>
-          <a:lstStyle/>
-          <a:p>
-            <a:pPr algn="ctr"/>
-          </a:p>
-        </p:txBody>
-      </p:sp>
-      <p:sp>
-        <p:nvSpPr>
-          <p:cNvPr id="3" name="Rectangle 2"/>
-          <p:cNvSpPr/>
-          <p:nvPr/>
-        </p:nvSpPr>
-        <p:spPr>
-          <a:xfrm>
-            <a:off x="0" y="0"/>
-            <a:ext cx="12191695" cy="109728"/>
-          </a:xfrm>
-          <a:prstGeom prst="rect">
-            <a:avLst/>
-          </a:prstGeom>
-          <a:solidFill>
-            <a:srgbClr val="10B981"/>
-          </a:solidFill>
-          <a:ln>
-            <a:noFill/>
-          </a:ln>
-          <a:effectLst/>
-        </p:spPr>
-        <p:style>
-          <a:lnRef idx="1">
-            <a:schemeClr val="accent1"/>
-          </a:lnRef>
-          <a:fillRef idx="3">
-            <a:schemeClr val="accent1"/>
-          </a:fillRef>
-          <a:effectRef idx="2">
-            <a:schemeClr val="accent1"/>
-          </a:effectRef>
-          <a:fontRef idx="minor">
-            <a:schemeClr val="lt1"/>
-          </a:fontRef>
-        </p:style>
-        <p:txBody>
-          <a:bodyPr rtlCol="0" anchor="ctr"/>
-          <a:lstStyle/>
-          <a:p>
-            <a:pPr algn="ctr"/>
-          </a:p>
-        </p:txBody>
-      </p:sp>
-      <p:sp>
-        <p:nvSpPr>
-          <p:cNvPr id="4" name="Rectangle 3"/>
-          <p:cNvSpPr/>
-          <p:nvPr/>
-        </p:nvSpPr>
-        <p:spPr>
-          <a:xfrm>
-            <a:off x="0" y="6784848"/>
-            <a:ext cx="12191695" cy="73152"/>
-          </a:xfrm>
-          <a:prstGeom prst="rect">
-            <a:avLst/>
-          </a:prstGeom>
-          <a:solidFill>
-            <a:srgbClr val="0B1220"/>
-          </a:solidFill>
-          <a:ln>
-            <a:noFill/>
-          </a:ln>
-          <a:effectLst/>
-        </p:spPr>
-        <p:style>
-          <a:lnRef idx="1">
-            <a:schemeClr val="accent1"/>
-          </a:lnRef>
-          <a:fillRef idx="3">
-            <a:schemeClr val="accent1"/>
-          </a:fillRef>
-          <a:effectRef idx="2">
-            <a:schemeClr val="accent1"/>
-          </a:effectRef>
-          <a:fontRef idx="minor">
-            <a:schemeClr val="lt1"/>
-          </a:fontRef>
-        </p:style>
-        <p:txBody>
-          <a:bodyPr rtlCol="0" anchor="ctr"/>
-          <a:lstStyle/>
-          <a:p>
-            <a:pPr algn="ctr"/>
-          </a:p>
-        </p:txBody>
-      </p:sp>
-      <p:sp>
-        <p:nvSpPr>
-          <p:cNvPr id="5" name="TextBox 4"/>
-          <p:cNvSpPr txBox="1"/>
-          <p:nvPr/>
-        </p:nvSpPr>
-        <p:spPr>
-          <a:xfrm>
-            <a:off x="566928" y="320040"/>
-            <a:ext cx="7315200" cy="228600"/>
-          </a:xfrm>
-          <a:prstGeom prst="rect">
-            <a:avLst/>
-          </a:prstGeom>
-          <a:noFill/>
-        </p:spPr>
-        <p:txBody>
-          <a:bodyPr wrap="square" anchor="t">
-            <a:noAutofit/>
-          </a:bodyPr>
-          <a:lstStyle/>
-          <a:p>
-            <a:pPr algn="l"/>
-            <a:r>
-              <a:rPr sz="1100" b="1">
-                <a:solidFill>
-                  <a:srgbClr val="047857"/>
-                </a:solidFill>
-                <a:latin typeface="Segoe UI"/>
-              </a:rPr>
-              <a:t>DISEÑO DE CLASES</a:t>
-            </a:r>
-          </a:p>
-        </p:txBody>
-      </p:sp>
-      <p:sp>
-        <p:nvSpPr>
-          <p:cNvPr id="6" name="TextBox 5"/>
-          <p:cNvSpPr txBox="1"/>
-          <p:nvPr/>
-        </p:nvSpPr>
-        <p:spPr>
-          <a:xfrm>
-            <a:off x="548640" y="566928"/>
-            <a:ext cx="10698480" cy="548640"/>
-          </a:xfrm>
-          <a:prstGeom prst="rect">
-            <a:avLst/>
-          </a:prstGeom>
-          <a:noFill/>
-        </p:spPr>
-        <p:txBody>
-          <a:bodyPr wrap="square" anchor="t">
-            <a:noAutofit/>
-          </a:bodyPr>
-          <a:lstStyle/>
-          <a:p>
-            <a:pPr algn="l"/>
-            <a:r>
-              <a:rPr sz="2600" b="1">
-                <a:solidFill>
-                  <a:srgbClr val="0B1220"/>
-                </a:solidFill>
-                <a:latin typeface="Segoe UI Semibold"/>
-              </a:rPr>
-              <a:t>El modelo del sistema (UML)</a:t>
-            </a:r>
-          </a:p>
-        </p:txBody>
-      </p:sp>
-      <p:sp>
-        <p:nvSpPr>
-          <p:cNvPr id="7" name="Rectangle 6"/>
-          <p:cNvSpPr/>
-          <p:nvPr/>
-        </p:nvSpPr>
-        <p:spPr>
-          <a:xfrm>
-            <a:off x="566928" y="1179576"/>
-            <a:ext cx="11064240" cy="15240"/>
-          </a:xfrm>
-          <a:prstGeom prst="rect">
-            <a:avLst/>
-          </a:prstGeom>
-          <a:solidFill>
-            <a:srgbClr val="E2E8F0"/>
-          </a:solidFill>
-          <a:ln>
-            <a:noFill/>
-          </a:ln>
-          <a:effectLst/>
-        </p:spPr>
-        <p:style>
-          <a:lnRef idx="1">
-            <a:schemeClr val="accent1"/>
-          </a:lnRef>
-          <a:fillRef idx="3">
-            <a:schemeClr val="accent1"/>
-          </a:fillRef>
-          <a:effectRef idx="2">
-            <a:schemeClr val="accent1"/>
-          </a:effectRef>
-          <a:fontRef idx="minor">
-            <a:schemeClr val="lt1"/>
-          </a:fontRef>
-        </p:style>
-        <p:txBody>
-          <a:bodyPr rtlCol="0" anchor="ctr"/>
-          <a:lstStyle/>
-          <a:p>
-            <a:pPr algn="ctr"/>
-          </a:p>
-        </p:txBody>
-      </p:sp>
-      <p:sp>
-        <p:nvSpPr>
-          <p:cNvPr id="8" name="TextBox 7"/>
-          <p:cNvSpPr txBox="1"/>
-          <p:nvPr/>
-        </p:nvSpPr>
-        <p:spPr>
-          <a:xfrm>
-            <a:off x="566928" y="6528816"/>
-            <a:ext cx="8229600" cy="182880"/>
-          </a:xfrm>
-          <a:prstGeom prst="rect">
-            <a:avLst/>
-          </a:prstGeom>
-          <a:noFill/>
-        </p:spPr>
-        <p:txBody>
-          <a:bodyPr wrap="square" anchor="t">
-            <a:noAutofit/>
-          </a:bodyPr>
-          <a:lstStyle/>
-          <a:p>
-            <a:pPr algn="l"/>
-            <a:r>
-              <a:rPr sz="800" b="0">
-                <a:solidFill>
-                  <a:srgbClr val="64748B"/>
-                </a:solidFill>
-                <a:latin typeface="Segoe UI"/>
-              </a:rPr>
-              <a:t>Sistema de Gestión de Eventos · Paradigmas de la Programación · FP-UNA 2026</a:t>
-            </a:r>
-          </a:p>
-        </p:txBody>
-      </p:sp>
-      <p:sp>
-        <p:nvSpPr>
-          <p:cNvPr id="9" name="TextBox 8"/>
-          <p:cNvSpPr txBox="1"/>
-          <p:nvPr/>
-        </p:nvSpPr>
-        <p:spPr>
-          <a:xfrm>
-            <a:off x="11192256" y="6492240"/>
-            <a:ext cx="548640" cy="201168"/>
-          </a:xfrm>
-          <a:prstGeom prst="rect">
-            <a:avLst/>
-          </a:prstGeom>
-          <a:noFill/>
-        </p:spPr>
-        <p:txBody>
-          <a:bodyPr wrap="square" anchor="t">
-            <a:noAutofit/>
-          </a:bodyPr>
-          <a:lstStyle/>
-          <a:p>
-            <a:pPr algn="r"/>
-            <a:r>
-              <a:rPr sz="900" b="1">
-                <a:solidFill>
-                  <a:srgbClr val="64748B"/>
-                </a:solidFill>
-                <a:latin typeface="Segoe UI"/>
-              </a:rPr>
-              <a:t>12</a:t>
-            </a:r>
-          </a:p>
-        </p:txBody>
-      </p:sp>
-      <p:sp>
-        <p:nvSpPr>
-          <p:cNvPr id="10" name="Rounded Rectangle 9"/>
-          <p:cNvSpPr/>
-          <p:nvPr/>
-        </p:nvSpPr>
-        <p:spPr>
-          <a:xfrm>
-            <a:off x="621792" y="1371600"/>
-            <a:ext cx="2537653" cy="4791456"/>
-          </a:xfrm>
-          <a:prstGeom prst="roundRect">
-            <a:avLst/>
-          </a:prstGeom>
-          <a:solidFill>
-            <a:srgbClr val="FFFFFF"/>
-          </a:solidFill>
-          <a:ln w="9525">
-            <a:solidFill>
-              <a:srgbClr val="E2E8F0"/>
-            </a:solidFill>
-          </a:ln>
-          <a:effectLst/>
-        </p:spPr>
-        <p:style>
-          <a:lnRef idx="1">
-            <a:schemeClr val="accent1"/>
-          </a:lnRef>
-          <a:fillRef idx="3">
-            <a:schemeClr val="accent1"/>
-          </a:fillRef>
-          <a:effectRef idx="2">
-            <a:schemeClr val="accent1"/>
-          </a:effectRef>
-          <a:fontRef idx="minor">
-            <a:schemeClr val="lt1"/>
-          </a:fontRef>
-        </p:style>
-        <p:txBody>
-          <a:bodyPr rtlCol="0" anchor="ctr"/>
-          <a:lstStyle/>
-          <a:p>
-            <a:pPr algn="ctr"/>
-          </a:p>
-        </p:txBody>
-      </p:sp>
-      <p:pic>
-        <p:nvPicPr>
-          <p:cNvPr id="11" name="Picture 10" descr="diagrama_G15.png"/>
-          <p:cNvPicPr>
-            <a:picLocks noChangeAspect="1"/>
-          </p:cNvPicPr>
-          <p:nvPr/>
-        </p:nvPicPr>
-        <p:blipFill>
-          <a:blip r:embed="rId2"/>
-          <a:stretch>
-            <a:fillRect/>
-          </a:stretch>
-        </p:blipFill>
-        <p:spPr>
-          <a:xfrm>
-            <a:off x="731520" y="1481328"/>
-            <a:ext cx="2318197" cy="4572000"/>
-          </a:xfrm>
-          <a:prstGeom prst="rect">
-            <a:avLst/>
-          </a:prstGeom>
-        </p:spPr>
-      </p:pic>
-      <p:sp>
-        <p:nvSpPr>
-          <p:cNvPr id="12" name="TextBox 11"/>
-          <p:cNvSpPr txBox="1"/>
-          <p:nvPr/>
-        </p:nvSpPr>
-        <p:spPr>
-          <a:xfrm>
-            <a:off x="7040880" y="1417320"/>
-            <a:ext cx="4572000" cy="365760"/>
-          </a:xfrm>
-          <a:prstGeom prst="rect">
-            <a:avLst/>
-          </a:prstGeom>
-          <a:noFill/>
-        </p:spPr>
-        <p:txBody>
-          <a:bodyPr wrap="square" anchor="t">
-            <a:noAutofit/>
-          </a:bodyPr>
-          <a:lstStyle/>
-          <a:p>
-            <a:pPr algn="l"/>
-            <a:r>
-              <a:rPr sz="1600" b="1">
-                <a:solidFill>
-                  <a:srgbClr val="0B1220"/>
-                </a:solidFill>
-                <a:latin typeface="Segoe UI Semibold"/>
-              </a:rPr>
-              <a:t>Cómo leer el diagrama</a:t>
-            </a:r>
-          </a:p>
-        </p:txBody>
-      </p:sp>
-      <p:sp>
-        <p:nvSpPr>
-          <p:cNvPr id="13" name="Rounded Rectangle 12"/>
-          <p:cNvSpPr/>
-          <p:nvPr/>
-        </p:nvSpPr>
-        <p:spPr>
-          <a:xfrm>
-            <a:off x="7040880" y="1965960"/>
-            <a:ext cx="4572000" cy="1143000"/>
-          </a:xfrm>
-          <a:prstGeom prst="roundRect">
-            <a:avLst/>
-          </a:prstGeom>
-          <a:solidFill>
-            <a:srgbClr val="FFFFFF"/>
-          </a:solidFill>
-          <a:ln w="9525">
-            <a:solidFill>
-              <a:srgbClr val="E2E8F0"/>
-            </a:solidFill>
-          </a:ln>
-          <a:effectLst/>
-        </p:spPr>
-        <p:style>
-          <a:lnRef idx="1">
-            <a:schemeClr val="accent1"/>
-          </a:lnRef>
-          <a:fillRef idx="3">
-            <a:schemeClr val="accent1"/>
-          </a:fillRef>
-          <a:effectRef idx="2">
-            <a:schemeClr val="accent1"/>
-          </a:effectRef>
-          <a:fontRef idx="minor">
-            <a:schemeClr val="lt1"/>
-          </a:fontRef>
-        </p:style>
-        <p:txBody>
-          <a:bodyPr rtlCol="0" anchor="ctr"/>
-          <a:lstStyle/>
-          <a:p>
-            <a:pPr algn="ctr"/>
-          </a:p>
-        </p:txBody>
-      </p:sp>
-      <p:sp>
-        <p:nvSpPr>
-          <p:cNvPr id="14" name="Rectangle 13"/>
-          <p:cNvSpPr/>
-          <p:nvPr/>
-        </p:nvSpPr>
-        <p:spPr>
-          <a:xfrm>
-            <a:off x="7040880" y="1965960"/>
-            <a:ext cx="73152" cy="1143000"/>
-          </a:xfrm>
-          <a:prstGeom prst="rect">
-            <a:avLst/>
-          </a:prstGeom>
-          <a:solidFill>
-            <a:srgbClr val="10B981"/>
-          </a:solidFill>
-          <a:ln>
-            <a:noFill/>
-          </a:ln>
-          <a:effectLst/>
-        </p:spPr>
-        <p:style>
-          <a:lnRef idx="1">
-            <a:schemeClr val="accent1"/>
-          </a:lnRef>
-          <a:fillRef idx="3">
-            <a:schemeClr val="accent1"/>
-          </a:fillRef>
-          <a:effectRef idx="2">
-            <a:schemeClr val="accent1"/>
-          </a:effectRef>
-          <a:fontRef idx="minor">
-            <a:schemeClr val="lt1"/>
-          </a:fontRef>
-        </p:style>
-        <p:txBody>
-          <a:bodyPr rtlCol="0" anchor="ctr"/>
-          <a:lstStyle/>
-          <a:p>
-            <a:pPr algn="ctr"/>
-          </a:p>
-        </p:txBody>
-      </p:sp>
-      <p:sp>
-        <p:nvSpPr>
-          <p:cNvPr id="15" name="TextBox 14"/>
-          <p:cNvSpPr txBox="1"/>
-          <p:nvPr/>
-        </p:nvSpPr>
-        <p:spPr>
-          <a:xfrm>
-            <a:off x="7269480" y="2093976"/>
-            <a:ext cx="4160520" cy="320040"/>
-          </a:xfrm>
-          <a:prstGeom prst="rect">
-            <a:avLst/>
-          </a:prstGeom>
-          <a:noFill/>
-        </p:spPr>
-        <p:txBody>
-          <a:bodyPr wrap="square" anchor="t">
-            <a:noAutofit/>
-          </a:bodyPr>
-          <a:lstStyle/>
-          <a:p>
-            <a:pPr algn="l"/>
-            <a:r>
-              <a:rPr sz="1400" b="1">
-                <a:solidFill>
-                  <a:srgbClr val="0B1220"/>
-                </a:solidFill>
-                <a:latin typeface="Segoe UI Semibold"/>
-              </a:rPr>
-              <a:t>Herencia</a:t>
-            </a:r>
-          </a:p>
-        </p:txBody>
-      </p:sp>
-      <p:sp>
-        <p:nvSpPr>
-          <p:cNvPr id="16" name="TextBox 15"/>
-          <p:cNvSpPr txBox="1"/>
-          <p:nvPr/>
-        </p:nvSpPr>
-        <p:spPr>
-          <a:xfrm>
-            <a:off x="7269480" y="2468880"/>
-            <a:ext cx="4160520" cy="548640"/>
-          </a:xfrm>
-          <a:prstGeom prst="rect">
-            <a:avLst/>
-          </a:prstGeom>
-          <a:noFill/>
-        </p:spPr>
-        <p:txBody>
-          <a:bodyPr wrap="square" anchor="t">
-            <a:noAutofit/>
-          </a:bodyPr>
-          <a:lstStyle/>
-          <a:p>
-            <a:pPr algn="l"/>
-            <a:r>
-              <a:rPr sz="1100" b="0">
-                <a:solidFill>
-                  <a:srgbClr val="111827"/>
-                </a:solidFill>
-                <a:latin typeface="Segoe UI"/>
-              </a:rPr>
-              <a:t>EventoDeportivo ES una AgendaEventos especializada (triángulo hueco).</a:t>
-            </a:r>
-          </a:p>
-        </p:txBody>
-      </p:sp>
-      <p:sp>
-        <p:nvSpPr>
-          <p:cNvPr id="17" name="Rounded Rectangle 16"/>
-          <p:cNvSpPr/>
-          <p:nvPr/>
-        </p:nvSpPr>
-        <p:spPr>
-          <a:xfrm>
-            <a:off x="7040880" y="3291839"/>
-            <a:ext cx="4572000" cy="1143000"/>
-          </a:xfrm>
-          <a:prstGeom prst="roundRect">
-            <a:avLst/>
-          </a:prstGeom>
-          <a:solidFill>
-            <a:srgbClr val="FFFFFF"/>
-          </a:solidFill>
-          <a:ln w="9525">
-            <a:solidFill>
-              <a:srgbClr val="E2E8F0"/>
-            </a:solidFill>
-          </a:ln>
-          <a:effectLst/>
-        </p:spPr>
-        <p:style>
-          <a:lnRef idx="1">
-            <a:schemeClr val="accent1"/>
-          </a:lnRef>
-          <a:fillRef idx="3">
-            <a:schemeClr val="accent1"/>
-          </a:fillRef>
-          <a:effectRef idx="2">
-            <a:schemeClr val="accent1"/>
-          </a:effectRef>
-          <a:fontRef idx="minor">
-            <a:schemeClr val="lt1"/>
-          </a:fontRef>
-        </p:style>
-        <p:txBody>
-          <a:bodyPr rtlCol="0" anchor="ctr"/>
-          <a:lstStyle/>
-          <a:p>
-            <a:pPr algn="ctr"/>
-          </a:p>
-        </p:txBody>
-      </p:sp>
-      <p:sp>
-        <p:nvSpPr>
-          <p:cNvPr id="18" name="Rectangle 17"/>
-          <p:cNvSpPr/>
-          <p:nvPr/>
-        </p:nvSpPr>
-        <p:spPr>
-          <a:xfrm>
-            <a:off x="7040880" y="3291839"/>
-            <a:ext cx="73152" cy="1143000"/>
-          </a:xfrm>
-          <a:prstGeom prst="rect">
-            <a:avLst/>
-          </a:prstGeom>
-          <a:solidFill>
-            <a:srgbClr val="2563EB"/>
-          </a:solidFill>
-          <a:ln>
-            <a:noFill/>
-          </a:ln>
-          <a:effectLst/>
-        </p:spPr>
-        <p:style>
-          <a:lnRef idx="1">
-            <a:schemeClr val="accent1"/>
-          </a:lnRef>
-          <a:fillRef idx="3">
-            <a:schemeClr val="accent1"/>
-          </a:fillRef>
-          <a:effectRef idx="2">
-            <a:schemeClr val="accent1"/>
-          </a:effectRef>
-          <a:fontRef idx="minor">
-            <a:schemeClr val="lt1"/>
-          </a:fontRef>
-        </p:style>
-        <p:txBody>
-          <a:bodyPr rtlCol="0" anchor="ctr"/>
-          <a:lstStyle/>
-          <a:p>
-            <a:pPr algn="ctr"/>
-          </a:p>
-        </p:txBody>
-      </p:sp>
-      <p:sp>
-        <p:nvSpPr>
-          <p:cNvPr id="19" name="TextBox 18"/>
-          <p:cNvSpPr txBox="1"/>
-          <p:nvPr/>
-        </p:nvSpPr>
-        <p:spPr>
-          <a:xfrm>
-            <a:off x="7269480" y="3419856"/>
-            <a:ext cx="4160520" cy="320040"/>
-          </a:xfrm>
-          <a:prstGeom prst="rect">
-            <a:avLst/>
-          </a:prstGeom>
-          <a:noFill/>
-        </p:spPr>
-        <p:txBody>
-          <a:bodyPr wrap="square" anchor="t">
-            <a:noAutofit/>
-          </a:bodyPr>
-          <a:lstStyle/>
-          <a:p>
-            <a:pPr algn="l"/>
-            <a:r>
-              <a:rPr sz="1400" b="1">
-                <a:solidFill>
-                  <a:srgbClr val="0B1220"/>
-                </a:solidFill>
-                <a:latin typeface="Segoe UI Semibold"/>
-              </a:rPr>
-              <a:t>Composición</a:t>
-            </a:r>
-          </a:p>
-        </p:txBody>
-      </p:sp>
-      <p:sp>
-        <p:nvSpPr>
-          <p:cNvPr id="20" name="TextBox 19"/>
-          <p:cNvSpPr txBox="1"/>
-          <p:nvPr/>
-        </p:nvSpPr>
-        <p:spPr>
-          <a:xfrm>
-            <a:off x="7269480" y="3794759"/>
-            <a:ext cx="4160520" cy="548640"/>
-          </a:xfrm>
-          <a:prstGeom prst="rect">
-            <a:avLst/>
-          </a:prstGeom>
-          <a:noFill/>
-        </p:spPr>
-        <p:txBody>
-          <a:bodyPr wrap="square" anchor="t">
-            <a:noAutofit/>
-          </a:bodyPr>
-          <a:lstStyle/>
-          <a:p>
-            <a:pPr algn="l"/>
-            <a:r>
-              <a:rPr sz="1100" b="0">
-                <a:solidFill>
-                  <a:srgbClr val="111827"/>
-                </a:solidFill>
-                <a:latin typeface="Segoe UI"/>
-              </a:rPr>
-              <a:t>La agenda contiene de 0 a muchos Evento (rombo relleno, 1 a 0..*).</a:t>
-            </a:r>
-          </a:p>
-        </p:txBody>
-      </p:sp>
-      <p:sp>
-        <p:nvSpPr>
-          <p:cNvPr id="21" name="Rounded Rectangle 20"/>
-          <p:cNvSpPr/>
-          <p:nvPr/>
-        </p:nvSpPr>
-        <p:spPr>
-          <a:xfrm>
-            <a:off x="7040880" y="4617720"/>
-            <a:ext cx="4572000" cy="1143000"/>
-          </a:xfrm>
-          <a:prstGeom prst="roundRect">
-            <a:avLst/>
-          </a:prstGeom>
-          <a:solidFill>
-            <a:srgbClr val="FFFFFF"/>
-          </a:solidFill>
-          <a:ln w="9525">
-            <a:solidFill>
-              <a:srgbClr val="E2E8F0"/>
-            </a:solidFill>
-          </a:ln>
-          <a:effectLst/>
-        </p:spPr>
-        <p:style>
-          <a:lnRef idx="1">
-            <a:schemeClr val="accent1"/>
-          </a:lnRef>
-          <a:fillRef idx="3">
-            <a:schemeClr val="accent1"/>
-          </a:fillRef>
-          <a:effectRef idx="2">
-            <a:schemeClr val="accent1"/>
-          </a:effectRef>
-          <a:fontRef idx="minor">
-            <a:schemeClr val="lt1"/>
-          </a:fontRef>
-        </p:style>
-        <p:txBody>
-          <a:bodyPr rtlCol="0" anchor="ctr"/>
-          <a:lstStyle/>
-          <a:p>
-            <a:pPr algn="ctr"/>
-          </a:p>
-        </p:txBody>
-      </p:sp>
-      <p:sp>
-        <p:nvSpPr>
-          <p:cNvPr id="22" name="Rectangle 21"/>
-          <p:cNvSpPr/>
-          <p:nvPr/>
-        </p:nvSpPr>
-        <p:spPr>
-          <a:xfrm>
-            <a:off x="7040880" y="4617720"/>
-            <a:ext cx="73152" cy="1143000"/>
-          </a:xfrm>
-          <a:prstGeom prst="rect">
-            <a:avLst/>
-          </a:prstGeom>
-          <a:solidFill>
-            <a:srgbClr val="F59E0B"/>
-          </a:solidFill>
-          <a:ln>
-            <a:noFill/>
-          </a:ln>
-          <a:effectLst/>
-        </p:spPr>
-        <p:style>
-          <a:lnRef idx="1">
-            <a:schemeClr val="accent1"/>
-          </a:lnRef>
-          <a:fillRef idx="3">
-            <a:schemeClr val="accent1"/>
-          </a:fillRef>
-          <a:effectRef idx="2">
-            <a:schemeClr val="accent1"/>
-          </a:effectRef>
-          <a:fontRef idx="minor">
-            <a:schemeClr val="lt1"/>
-          </a:fontRef>
-        </p:style>
-        <p:txBody>
-          <a:bodyPr rtlCol="0" anchor="ctr"/>
-          <a:lstStyle/>
-          <a:p>
-            <a:pPr algn="ctr"/>
-          </a:p>
-        </p:txBody>
-      </p:sp>
-      <p:sp>
-        <p:nvSpPr>
-          <p:cNvPr id="23" name="TextBox 22"/>
-          <p:cNvSpPr txBox="1"/>
-          <p:nvPr/>
-        </p:nvSpPr>
-        <p:spPr>
-          <a:xfrm>
-            <a:off x="7269480" y="4745736"/>
-            <a:ext cx="4160520" cy="320040"/>
-          </a:xfrm>
-          <a:prstGeom prst="rect">
-            <a:avLst/>
-          </a:prstGeom>
-          <a:noFill/>
-        </p:spPr>
-        <p:txBody>
-          <a:bodyPr wrap="square" anchor="t">
-            <a:noAutofit/>
-          </a:bodyPr>
-          <a:lstStyle/>
-          <a:p>
-            <a:pPr algn="l"/>
-            <a:r>
-              <a:rPr sz="1400" b="1">
-                <a:solidFill>
-                  <a:srgbClr val="0B1220"/>
-                </a:solidFill>
-                <a:latin typeface="Segoe UI Semibold"/>
-              </a:rPr>
-              <a:t>Validación</a:t>
-            </a:r>
-          </a:p>
-        </p:txBody>
-      </p:sp>
-      <p:sp>
-        <p:nvSpPr>
-          <p:cNvPr id="24" name="TextBox 23"/>
-          <p:cNvSpPr txBox="1"/>
-          <p:nvPr/>
-        </p:nvSpPr>
-        <p:spPr>
-          <a:xfrm>
-            <a:off x="7269480" y="5120640"/>
-            <a:ext cx="4160520" cy="548640"/>
-          </a:xfrm>
-          <a:prstGeom prst="rect">
-            <a:avLst/>
-          </a:prstGeom>
-          <a:noFill/>
-        </p:spPr>
-        <p:txBody>
-          <a:bodyPr wrap="square" anchor="t">
-            <a:noAutofit/>
-          </a:bodyPr>
-          <a:lstStyle/>
-          <a:p>
-            <a:pPr algn="l"/>
-            <a:r>
-              <a:rPr sz="1100" b="0">
-                <a:solidFill>
-                  <a:srgbClr val="111827"/>
-                </a:solidFill>
-                <a:latin typeface="Segoe UI"/>
-              </a:rPr>
-              <a:t>Atributos sensibles protegidos con properties (fecha, cupo, ventas).</a:t>
-            </a:r>
-          </a:p>
-        </p:txBody>
-      </p:sp>
     </p:spTree>
   </p:cSld>
   <p:clrMapOvr>

</xml_diff>